<commit_message>
ppt with voice over
</commit_message>
<xml_diff>
--- a/Part2_Elementary_Data_Structures_Presentation.pptx
+++ b/Part2_Elementary_Data_Structures_Presentation.pptx
@@ -3989,7 +3989,9 @@
         </p:nvSpPr>
         <p:spPr/>
         <p:txBody>
-          <a:bodyPr/>
+          <a:bodyPr>
+            <a:normAutofit fontScale="70000" lnSpcReduction="20000"/>
+          </a:bodyPr>
           <a:lstStyle/>
           <a:p>
             <a:r>
@@ -4008,11 +4010,143 @@
           </a:p>
         </p:txBody>
       </p:sp>
+      <p:pic>
+        <p:nvPicPr>
+          <p:cNvPr id="13" name="Audio 12">
+            <a:extLst>
+              <a:ext uri="{FF2B5EF4-FFF2-40B4-BE49-F238E27FC236}">
+                <a16:creationId xmlns:a16="http://schemas.microsoft.com/office/drawing/2014/main" id="{DC6B544E-4252-27DD-776B-6BCC895A6889}"/>
+              </a:ext>
+            </a:extLst>
+          </p:cNvPr>
+          <p:cNvPicPr>
+            <a:picLocks noChangeAspect="1"/>
+          </p:cNvPicPr>
+          <p:nvPr>
+            <a:audioFile r:link="rId2"/>
+            <p:extLst>
+              <p:ext uri="{DAA4B4D4-6D71-4841-9C94-3DE7FCFB9230}">
+                <p14:media xmlns:p14="http://schemas.microsoft.com/office/powerpoint/2010/main" r:embed="rId1"/>
+              </p:ext>
+            </p:extLst>
+          </p:nvPr>
+        </p:nvPicPr>
+        <p:blipFill>
+          <a:blip r:embed="rId5"/>
+          <a:stretch>
+            <a:fillRect/>
+          </a:stretch>
+        </p:blipFill>
+        <p:spPr>
+          <a:xfrm>
+            <a:off x="8178800" y="5892800"/>
+            <a:ext cx="812800" cy="812800"/>
+          </a:xfrm>
+          <a:prstGeom prst="rect">
+            <a:avLst/>
+          </a:prstGeom>
+        </p:spPr>
+      </p:pic>
     </p:spTree>
   </p:cSld>
   <p:clrMapOvr>
     <a:masterClrMapping/>
   </p:clrMapOvr>
+  <mc:AlternateContent xmlns:mc="http://schemas.openxmlformats.org/markup-compatibility/2006">
+    <mc:Choice xmlns:p14="http://schemas.microsoft.com/office/powerpoint/2010/main" Requires="p14">
+      <p:transition spd="slow" p14:dur="2000" advTm="31904"/>
+    </mc:Choice>
+    <mc:Fallback>
+      <p:transition spd="slow" advTm="31904"/>
+    </mc:Fallback>
+  </mc:AlternateContent>
+  <p:timing>
+    <p:tnLst>
+      <p:par>
+        <p:cTn id="1" dur="indefinite" restart="never" nodeType="tmRoot">
+          <p:childTnLst>
+            <p:seq concurrent="1" nextAc="seek">
+              <p:cTn id="2" dur="indefinite" nodeType="mainSeq">
+                <p:childTnLst>
+                  <p:par>
+                    <p:cTn id="3" fill="hold">
+                      <p:stCondLst>
+                        <p:cond delay="indefinite"/>
+                        <p:cond evt="onBegin" delay="0">
+                          <p:tn val="2"/>
+                        </p:cond>
+                      </p:stCondLst>
+                      <p:childTnLst>
+                        <p:par>
+                          <p:cTn id="4" fill="hold">
+                            <p:stCondLst>
+                              <p:cond delay="0"/>
+                            </p:stCondLst>
+                            <p:childTnLst>
+                              <p:par>
+                                <p:cTn id="5" presetID="1" presetClass="mediacall" presetSubtype="0" fill="hold" nodeType="afterEffect">
+                                  <p:stCondLst>
+                                    <p:cond delay="0"/>
+                                  </p:stCondLst>
+                                  <p:childTnLst>
+                                    <p:cmd type="call" cmd="playFrom(0.0)">
+                                      <p:cBhvr>
+                                        <p:cTn id="6" dur="1" fill="hold"/>
+                                        <p:tgtEl>
+                                          <p:spTgt spid="13"/>
+                                        </p:tgtEl>
+                                      </p:cBhvr>
+                                    </p:cmd>
+                                  </p:childTnLst>
+                                </p:cTn>
+                              </p:par>
+                            </p:childTnLst>
+                          </p:cTn>
+                        </p:par>
+                      </p:childTnLst>
+                    </p:cTn>
+                  </p:par>
+                </p:childTnLst>
+              </p:cTn>
+              <p:prevCondLst>
+                <p:cond evt="onPrev" delay="0">
+                  <p:tgtEl>
+                    <p:sldTgt/>
+                  </p:tgtEl>
+                </p:cond>
+              </p:prevCondLst>
+              <p:nextCondLst>
+                <p:cond evt="onNext" delay="0">
+                  <p:tgtEl>
+                    <p:sldTgt/>
+                  </p:tgtEl>
+                </p:cond>
+              </p:nextCondLst>
+            </p:seq>
+            <p:audio isNarration="1">
+              <p:cMediaNode vol="80000" showWhenStopped="0">
+                <p:cTn id="7" fill="hold" display="0">
+                  <p:stCondLst>
+                    <p:cond delay="indefinite"/>
+                  </p:stCondLst>
+                  <p:endCondLst>
+                    <p:cond evt="onStopAudio" delay="0">
+                      <p:tgtEl>
+                        <p:sldTgt/>
+                      </p:tgtEl>
+                    </p:cond>
+                  </p:endCondLst>
+                </p:cTn>
+                <p:tgtEl>
+                  <p:spTgt spid="13"/>
+                </p:tgtEl>
+              </p:cMediaNode>
+            </p:audio>
+          </p:childTnLst>
+        </p:cTn>
+      </p:par>
+    </p:tnLst>
+  </p:timing>
 </p:sld>
 </file>
 
@@ -4125,11 +4259,143 @@
           </a:p>
         </p:txBody>
       </p:sp>
+      <p:pic>
+        <p:nvPicPr>
+          <p:cNvPr id="9" name="Audio 8">
+            <a:extLst>
+              <a:ext uri="{FF2B5EF4-FFF2-40B4-BE49-F238E27FC236}">
+                <a16:creationId xmlns:a16="http://schemas.microsoft.com/office/drawing/2014/main" id="{0A0FDFC1-D5FF-B9A9-9BC7-B43E2CED5180}"/>
+              </a:ext>
+            </a:extLst>
+          </p:cNvPr>
+          <p:cNvPicPr>
+            <a:picLocks noChangeAspect="1"/>
+          </p:cNvPicPr>
+          <p:nvPr>
+            <a:audioFile r:link="rId2"/>
+            <p:extLst>
+              <p:ext uri="{DAA4B4D4-6D71-4841-9C94-3DE7FCFB9230}">
+                <p14:media xmlns:p14="http://schemas.microsoft.com/office/powerpoint/2010/main" r:embed="rId1"/>
+              </p:ext>
+            </p:extLst>
+          </p:nvPr>
+        </p:nvPicPr>
+        <p:blipFill>
+          <a:blip r:embed="rId5"/>
+          <a:stretch>
+            <a:fillRect/>
+          </a:stretch>
+        </p:blipFill>
+        <p:spPr>
+          <a:xfrm>
+            <a:off x="8178800" y="5892800"/>
+            <a:ext cx="812800" cy="812800"/>
+          </a:xfrm>
+          <a:prstGeom prst="rect">
+            <a:avLst/>
+          </a:prstGeom>
+        </p:spPr>
+      </p:pic>
     </p:spTree>
   </p:cSld>
   <p:clrMapOvr>
     <a:masterClrMapping/>
   </p:clrMapOvr>
+  <mc:AlternateContent xmlns:mc="http://schemas.openxmlformats.org/markup-compatibility/2006">
+    <mc:Choice xmlns:p14="http://schemas.microsoft.com/office/powerpoint/2010/main" Requires="p14">
+      <p:transition spd="slow" p14:dur="2000" advTm="69504"/>
+    </mc:Choice>
+    <mc:Fallback>
+      <p:transition spd="slow" advTm="69504"/>
+    </mc:Fallback>
+  </mc:AlternateContent>
+  <p:timing>
+    <p:tnLst>
+      <p:par>
+        <p:cTn id="1" dur="indefinite" restart="never" nodeType="tmRoot">
+          <p:childTnLst>
+            <p:seq concurrent="1" nextAc="seek">
+              <p:cTn id="2" dur="indefinite" nodeType="mainSeq">
+                <p:childTnLst>
+                  <p:par>
+                    <p:cTn id="3" fill="hold">
+                      <p:stCondLst>
+                        <p:cond delay="indefinite"/>
+                        <p:cond evt="onBegin" delay="0">
+                          <p:tn val="2"/>
+                        </p:cond>
+                      </p:stCondLst>
+                      <p:childTnLst>
+                        <p:par>
+                          <p:cTn id="4" fill="hold">
+                            <p:stCondLst>
+                              <p:cond delay="0"/>
+                            </p:stCondLst>
+                            <p:childTnLst>
+                              <p:par>
+                                <p:cTn id="5" presetID="1" presetClass="mediacall" presetSubtype="0" fill="hold" nodeType="afterEffect">
+                                  <p:stCondLst>
+                                    <p:cond delay="0"/>
+                                  </p:stCondLst>
+                                  <p:childTnLst>
+                                    <p:cmd type="call" cmd="playFrom(0.0)">
+                                      <p:cBhvr>
+                                        <p:cTn id="6" dur="1" fill="hold"/>
+                                        <p:tgtEl>
+                                          <p:spTgt spid="9"/>
+                                        </p:tgtEl>
+                                      </p:cBhvr>
+                                    </p:cmd>
+                                  </p:childTnLst>
+                                </p:cTn>
+                              </p:par>
+                            </p:childTnLst>
+                          </p:cTn>
+                        </p:par>
+                      </p:childTnLst>
+                    </p:cTn>
+                  </p:par>
+                </p:childTnLst>
+              </p:cTn>
+              <p:prevCondLst>
+                <p:cond evt="onPrev" delay="0">
+                  <p:tgtEl>
+                    <p:sldTgt/>
+                  </p:tgtEl>
+                </p:cond>
+              </p:prevCondLst>
+              <p:nextCondLst>
+                <p:cond evt="onNext" delay="0">
+                  <p:tgtEl>
+                    <p:sldTgt/>
+                  </p:tgtEl>
+                </p:cond>
+              </p:nextCondLst>
+            </p:seq>
+            <p:audio isNarration="1">
+              <p:cMediaNode vol="80000" showWhenStopped="0">
+                <p:cTn id="7" fill="hold" display="0">
+                  <p:stCondLst>
+                    <p:cond delay="indefinite"/>
+                  </p:stCondLst>
+                  <p:endCondLst>
+                    <p:cond evt="onStopAudio" delay="0">
+                      <p:tgtEl>
+                        <p:sldTgt/>
+                      </p:tgtEl>
+                    </p:cond>
+                  </p:endCondLst>
+                </p:cTn>
+                <p:tgtEl>
+                  <p:spTgt spid="9"/>
+                </p:tgtEl>
+              </p:cMediaNode>
+            </p:audio>
+          </p:childTnLst>
+        </p:cTn>
+      </p:par>
+    </p:tnLst>
+  </p:timing>
 </p:sld>
 </file>
 
@@ -4242,11 +4508,143 @@
           </a:p>
         </p:txBody>
       </p:sp>
+      <p:pic>
+        <p:nvPicPr>
+          <p:cNvPr id="6" name="Audio 5">
+            <a:extLst>
+              <a:ext uri="{FF2B5EF4-FFF2-40B4-BE49-F238E27FC236}">
+                <a16:creationId xmlns:a16="http://schemas.microsoft.com/office/drawing/2014/main" id="{DB46E3EA-3C1B-D30A-CD2F-ABC45115D9DD}"/>
+              </a:ext>
+            </a:extLst>
+          </p:cNvPr>
+          <p:cNvPicPr>
+            <a:picLocks noChangeAspect="1"/>
+          </p:cNvPicPr>
+          <p:nvPr>
+            <a:audioFile r:link="rId2"/>
+            <p:extLst>
+              <p:ext uri="{DAA4B4D4-6D71-4841-9C94-3DE7FCFB9230}">
+                <p14:media xmlns:p14="http://schemas.microsoft.com/office/powerpoint/2010/main" r:embed="rId1"/>
+              </p:ext>
+            </p:extLst>
+          </p:nvPr>
+        </p:nvPicPr>
+        <p:blipFill>
+          <a:blip r:embed="rId5"/>
+          <a:stretch>
+            <a:fillRect/>
+          </a:stretch>
+        </p:blipFill>
+        <p:spPr>
+          <a:xfrm>
+            <a:off x="8178800" y="5892800"/>
+            <a:ext cx="812800" cy="812800"/>
+          </a:xfrm>
+          <a:prstGeom prst="rect">
+            <a:avLst/>
+          </a:prstGeom>
+        </p:spPr>
+      </p:pic>
     </p:spTree>
   </p:cSld>
   <p:clrMapOvr>
     <a:masterClrMapping/>
   </p:clrMapOvr>
+  <mc:AlternateContent xmlns:mc="http://schemas.openxmlformats.org/markup-compatibility/2006">
+    <mc:Choice xmlns:p14="http://schemas.microsoft.com/office/powerpoint/2010/main" Requires="p14">
+      <p:transition spd="slow" p14:dur="2000" advTm="81258"/>
+    </mc:Choice>
+    <mc:Fallback>
+      <p:transition spd="slow" advTm="81258"/>
+    </mc:Fallback>
+  </mc:AlternateContent>
+  <p:timing>
+    <p:tnLst>
+      <p:par>
+        <p:cTn id="1" dur="indefinite" restart="never" nodeType="tmRoot">
+          <p:childTnLst>
+            <p:seq concurrent="1" nextAc="seek">
+              <p:cTn id="2" dur="indefinite" nodeType="mainSeq">
+                <p:childTnLst>
+                  <p:par>
+                    <p:cTn id="3" fill="hold">
+                      <p:stCondLst>
+                        <p:cond delay="indefinite"/>
+                        <p:cond evt="onBegin" delay="0">
+                          <p:tn val="2"/>
+                        </p:cond>
+                      </p:stCondLst>
+                      <p:childTnLst>
+                        <p:par>
+                          <p:cTn id="4" fill="hold">
+                            <p:stCondLst>
+                              <p:cond delay="0"/>
+                            </p:stCondLst>
+                            <p:childTnLst>
+                              <p:par>
+                                <p:cTn id="5" presetID="1" presetClass="mediacall" presetSubtype="0" fill="hold" nodeType="afterEffect">
+                                  <p:stCondLst>
+                                    <p:cond delay="0"/>
+                                  </p:stCondLst>
+                                  <p:childTnLst>
+                                    <p:cmd type="call" cmd="playFrom(0.0)">
+                                      <p:cBhvr>
+                                        <p:cTn id="6" dur="1" fill="hold"/>
+                                        <p:tgtEl>
+                                          <p:spTgt spid="6"/>
+                                        </p:tgtEl>
+                                      </p:cBhvr>
+                                    </p:cmd>
+                                  </p:childTnLst>
+                                </p:cTn>
+                              </p:par>
+                            </p:childTnLst>
+                          </p:cTn>
+                        </p:par>
+                      </p:childTnLst>
+                    </p:cTn>
+                  </p:par>
+                </p:childTnLst>
+              </p:cTn>
+              <p:prevCondLst>
+                <p:cond evt="onPrev" delay="0">
+                  <p:tgtEl>
+                    <p:sldTgt/>
+                  </p:tgtEl>
+                </p:cond>
+              </p:prevCondLst>
+              <p:nextCondLst>
+                <p:cond evt="onNext" delay="0">
+                  <p:tgtEl>
+                    <p:sldTgt/>
+                  </p:tgtEl>
+                </p:cond>
+              </p:nextCondLst>
+            </p:seq>
+            <p:audio isNarration="1">
+              <p:cMediaNode vol="80000" showWhenStopped="0">
+                <p:cTn id="7" fill="hold" display="0">
+                  <p:stCondLst>
+                    <p:cond delay="indefinite"/>
+                  </p:stCondLst>
+                  <p:endCondLst>
+                    <p:cond evt="onStopAudio" delay="0">
+                      <p:tgtEl>
+                        <p:sldTgt/>
+                      </p:tgtEl>
+                    </p:cond>
+                  </p:endCondLst>
+                </p:cTn>
+                <p:tgtEl>
+                  <p:spTgt spid="6"/>
+                </p:tgtEl>
+              </p:cMediaNode>
+            </p:audio>
+          </p:childTnLst>
+        </p:cTn>
+      </p:par>
+    </p:tnLst>
+  </p:timing>
 </p:sld>
 </file>
 
@@ -4359,11 +4757,143 @@
           </a:p>
         </p:txBody>
       </p:sp>
+      <p:pic>
+        <p:nvPicPr>
+          <p:cNvPr id="6" name="Audio 5">
+            <a:extLst>
+              <a:ext uri="{FF2B5EF4-FFF2-40B4-BE49-F238E27FC236}">
+                <a16:creationId xmlns:a16="http://schemas.microsoft.com/office/drawing/2014/main" id="{6AED7311-9B1B-2F1E-B338-430524818721}"/>
+              </a:ext>
+            </a:extLst>
+          </p:cNvPr>
+          <p:cNvPicPr>
+            <a:picLocks noChangeAspect="1"/>
+          </p:cNvPicPr>
+          <p:nvPr>
+            <a:audioFile r:link="rId2"/>
+            <p:extLst>
+              <p:ext uri="{DAA4B4D4-6D71-4841-9C94-3DE7FCFB9230}">
+                <p14:media xmlns:p14="http://schemas.microsoft.com/office/powerpoint/2010/main" r:embed="rId1"/>
+              </p:ext>
+            </p:extLst>
+          </p:nvPr>
+        </p:nvPicPr>
+        <p:blipFill>
+          <a:blip r:embed="rId5"/>
+          <a:stretch>
+            <a:fillRect/>
+          </a:stretch>
+        </p:blipFill>
+        <p:spPr>
+          <a:xfrm>
+            <a:off x="8178800" y="5892800"/>
+            <a:ext cx="812800" cy="812800"/>
+          </a:xfrm>
+          <a:prstGeom prst="rect">
+            <a:avLst/>
+          </a:prstGeom>
+        </p:spPr>
+      </p:pic>
     </p:spTree>
   </p:cSld>
   <p:clrMapOvr>
     <a:masterClrMapping/>
   </p:clrMapOvr>
+  <mc:AlternateContent xmlns:mc="http://schemas.openxmlformats.org/markup-compatibility/2006">
+    <mc:Choice xmlns:p14="http://schemas.microsoft.com/office/powerpoint/2010/main" Requires="p14">
+      <p:transition spd="slow" p14:dur="2000" advTm="72288"/>
+    </mc:Choice>
+    <mc:Fallback>
+      <p:transition spd="slow" advTm="72288"/>
+    </mc:Fallback>
+  </mc:AlternateContent>
+  <p:timing>
+    <p:tnLst>
+      <p:par>
+        <p:cTn id="1" dur="indefinite" restart="never" nodeType="tmRoot">
+          <p:childTnLst>
+            <p:seq concurrent="1" nextAc="seek">
+              <p:cTn id="2" dur="indefinite" nodeType="mainSeq">
+                <p:childTnLst>
+                  <p:par>
+                    <p:cTn id="3" fill="hold">
+                      <p:stCondLst>
+                        <p:cond delay="indefinite"/>
+                        <p:cond evt="onBegin" delay="0">
+                          <p:tn val="2"/>
+                        </p:cond>
+                      </p:stCondLst>
+                      <p:childTnLst>
+                        <p:par>
+                          <p:cTn id="4" fill="hold">
+                            <p:stCondLst>
+                              <p:cond delay="0"/>
+                            </p:stCondLst>
+                            <p:childTnLst>
+                              <p:par>
+                                <p:cTn id="5" presetID="1" presetClass="mediacall" presetSubtype="0" fill="hold" nodeType="afterEffect">
+                                  <p:stCondLst>
+                                    <p:cond delay="0"/>
+                                  </p:stCondLst>
+                                  <p:childTnLst>
+                                    <p:cmd type="call" cmd="playFrom(0.0)">
+                                      <p:cBhvr>
+                                        <p:cTn id="6" dur="1" fill="hold"/>
+                                        <p:tgtEl>
+                                          <p:spTgt spid="6"/>
+                                        </p:tgtEl>
+                                      </p:cBhvr>
+                                    </p:cmd>
+                                  </p:childTnLst>
+                                </p:cTn>
+                              </p:par>
+                            </p:childTnLst>
+                          </p:cTn>
+                        </p:par>
+                      </p:childTnLst>
+                    </p:cTn>
+                  </p:par>
+                </p:childTnLst>
+              </p:cTn>
+              <p:prevCondLst>
+                <p:cond evt="onPrev" delay="0">
+                  <p:tgtEl>
+                    <p:sldTgt/>
+                  </p:tgtEl>
+                </p:cond>
+              </p:prevCondLst>
+              <p:nextCondLst>
+                <p:cond evt="onNext" delay="0">
+                  <p:tgtEl>
+                    <p:sldTgt/>
+                  </p:tgtEl>
+                </p:cond>
+              </p:nextCondLst>
+            </p:seq>
+            <p:audio isNarration="1">
+              <p:cMediaNode vol="80000" showWhenStopped="0">
+                <p:cTn id="7" fill="hold" display="0">
+                  <p:stCondLst>
+                    <p:cond delay="indefinite"/>
+                  </p:stCondLst>
+                  <p:endCondLst>
+                    <p:cond evt="onStopAudio" delay="0">
+                      <p:tgtEl>
+                        <p:sldTgt/>
+                      </p:tgtEl>
+                    </p:cond>
+                  </p:endCondLst>
+                </p:cTn>
+                <p:tgtEl>
+                  <p:spTgt spid="6"/>
+                </p:tgtEl>
+              </p:cMediaNode>
+            </p:audio>
+          </p:childTnLst>
+        </p:cTn>
+      </p:par>
+    </p:tnLst>
+  </p:timing>
 </p:sld>
 </file>
 
@@ -4393,7 +4923,7 @@
           <p:nvPr/>
         </p:nvPicPr>
         <p:blipFill>
-          <a:blip r:embed="rId3"/>
+          <a:blip r:embed="rId5"/>
           <a:stretch>
             <a:fillRect/>
           </a:stretch>
@@ -4447,11 +4977,143 @@
           </a:p>
         </p:txBody>
       </p:sp>
+      <p:pic>
+        <p:nvPicPr>
+          <p:cNvPr id="4" name="Audio 3">
+            <a:extLst>
+              <a:ext uri="{FF2B5EF4-FFF2-40B4-BE49-F238E27FC236}">
+                <a16:creationId xmlns:a16="http://schemas.microsoft.com/office/drawing/2014/main" id="{0711D6F1-28AA-0827-99BA-8137D50D993D}"/>
+              </a:ext>
+            </a:extLst>
+          </p:cNvPr>
+          <p:cNvPicPr>
+            <a:picLocks noChangeAspect="1"/>
+          </p:cNvPicPr>
+          <p:nvPr>
+            <a:audioFile r:link="rId2"/>
+            <p:extLst>
+              <p:ext uri="{DAA4B4D4-6D71-4841-9C94-3DE7FCFB9230}">
+                <p14:media xmlns:p14="http://schemas.microsoft.com/office/powerpoint/2010/main" r:embed="rId1"/>
+              </p:ext>
+            </p:extLst>
+          </p:nvPr>
+        </p:nvPicPr>
+        <p:blipFill>
+          <a:blip r:embed="rId6"/>
+          <a:stretch>
+            <a:fillRect/>
+          </a:stretch>
+        </p:blipFill>
+        <p:spPr>
+          <a:xfrm>
+            <a:off x="8178800" y="5892800"/>
+            <a:ext cx="812800" cy="812800"/>
+          </a:xfrm>
+          <a:prstGeom prst="rect">
+            <a:avLst/>
+          </a:prstGeom>
+        </p:spPr>
+      </p:pic>
     </p:spTree>
   </p:cSld>
   <p:clrMapOvr>
     <a:masterClrMapping/>
   </p:clrMapOvr>
+  <mc:AlternateContent xmlns:mc="http://schemas.openxmlformats.org/markup-compatibility/2006">
+    <mc:Choice xmlns:p14="http://schemas.microsoft.com/office/powerpoint/2010/main" Requires="p14">
+      <p:transition spd="slow" p14:dur="2000" advTm="28970"/>
+    </mc:Choice>
+    <mc:Fallback>
+      <p:transition spd="slow" advTm="28970"/>
+    </mc:Fallback>
+  </mc:AlternateContent>
+  <p:timing>
+    <p:tnLst>
+      <p:par>
+        <p:cTn id="1" dur="indefinite" restart="never" nodeType="tmRoot">
+          <p:childTnLst>
+            <p:seq concurrent="1" nextAc="seek">
+              <p:cTn id="2" dur="indefinite" nodeType="mainSeq">
+                <p:childTnLst>
+                  <p:par>
+                    <p:cTn id="3" fill="hold">
+                      <p:stCondLst>
+                        <p:cond delay="indefinite"/>
+                        <p:cond evt="onBegin" delay="0">
+                          <p:tn val="2"/>
+                        </p:cond>
+                      </p:stCondLst>
+                      <p:childTnLst>
+                        <p:par>
+                          <p:cTn id="4" fill="hold">
+                            <p:stCondLst>
+                              <p:cond delay="0"/>
+                            </p:stCondLst>
+                            <p:childTnLst>
+                              <p:par>
+                                <p:cTn id="5" presetID="1" presetClass="mediacall" presetSubtype="0" fill="hold" nodeType="afterEffect">
+                                  <p:stCondLst>
+                                    <p:cond delay="0"/>
+                                  </p:stCondLst>
+                                  <p:childTnLst>
+                                    <p:cmd type="call" cmd="playFrom(0.0)">
+                                      <p:cBhvr>
+                                        <p:cTn id="6" dur="1" fill="hold"/>
+                                        <p:tgtEl>
+                                          <p:spTgt spid="4"/>
+                                        </p:tgtEl>
+                                      </p:cBhvr>
+                                    </p:cmd>
+                                  </p:childTnLst>
+                                </p:cTn>
+                              </p:par>
+                            </p:childTnLst>
+                          </p:cTn>
+                        </p:par>
+                      </p:childTnLst>
+                    </p:cTn>
+                  </p:par>
+                </p:childTnLst>
+              </p:cTn>
+              <p:prevCondLst>
+                <p:cond evt="onPrev" delay="0">
+                  <p:tgtEl>
+                    <p:sldTgt/>
+                  </p:tgtEl>
+                </p:cond>
+              </p:prevCondLst>
+              <p:nextCondLst>
+                <p:cond evt="onNext" delay="0">
+                  <p:tgtEl>
+                    <p:sldTgt/>
+                  </p:tgtEl>
+                </p:cond>
+              </p:nextCondLst>
+            </p:seq>
+            <p:audio isNarration="1">
+              <p:cMediaNode vol="80000" showWhenStopped="0">
+                <p:cTn id="7" fill="hold" display="0">
+                  <p:stCondLst>
+                    <p:cond delay="indefinite"/>
+                  </p:stCondLst>
+                  <p:endCondLst>
+                    <p:cond evt="onStopAudio" delay="0">
+                      <p:tgtEl>
+                        <p:sldTgt/>
+                      </p:tgtEl>
+                    </p:cond>
+                  </p:endCondLst>
+                </p:cTn>
+                <p:tgtEl>
+                  <p:spTgt spid="4"/>
+                </p:tgtEl>
+              </p:cMediaNode>
+            </p:audio>
+          </p:childTnLst>
+        </p:cTn>
+      </p:par>
+    </p:tnLst>
+  </p:timing>
 </p:sld>
 </file>
 
@@ -4481,7 +5143,7 @@
           <p:nvPr/>
         </p:nvPicPr>
         <p:blipFill>
-          <a:blip r:embed="rId3"/>
+          <a:blip r:embed="rId5"/>
           <a:stretch>
             <a:fillRect/>
           </a:stretch>
@@ -4535,11 +5197,143 @@
           </a:p>
         </p:txBody>
       </p:sp>
+      <p:pic>
+        <p:nvPicPr>
+          <p:cNvPr id="3" name="Audio 2">
+            <a:extLst>
+              <a:ext uri="{FF2B5EF4-FFF2-40B4-BE49-F238E27FC236}">
+                <a16:creationId xmlns:a16="http://schemas.microsoft.com/office/drawing/2014/main" id="{C89A1735-A235-45C7-8B6E-D21AC29465A6}"/>
+              </a:ext>
+            </a:extLst>
+          </p:cNvPr>
+          <p:cNvPicPr>
+            <a:picLocks noChangeAspect="1"/>
+          </p:cNvPicPr>
+          <p:nvPr>
+            <a:audioFile r:link="rId2"/>
+            <p:extLst>
+              <p:ext uri="{DAA4B4D4-6D71-4841-9C94-3DE7FCFB9230}">
+                <p14:media xmlns:p14="http://schemas.microsoft.com/office/powerpoint/2010/main" r:embed="rId1"/>
+              </p:ext>
+            </p:extLst>
+          </p:nvPr>
+        </p:nvPicPr>
+        <p:blipFill>
+          <a:blip r:embed="rId6"/>
+          <a:stretch>
+            <a:fillRect/>
+          </a:stretch>
+        </p:blipFill>
+        <p:spPr>
+          <a:xfrm>
+            <a:off x="8178800" y="5892800"/>
+            <a:ext cx="812800" cy="812800"/>
+          </a:xfrm>
+          <a:prstGeom prst="rect">
+            <a:avLst/>
+          </a:prstGeom>
+        </p:spPr>
+      </p:pic>
     </p:spTree>
   </p:cSld>
   <p:clrMapOvr>
     <a:masterClrMapping/>
   </p:clrMapOvr>
+  <mc:AlternateContent xmlns:mc="http://schemas.openxmlformats.org/markup-compatibility/2006">
+    <mc:Choice xmlns:p14="http://schemas.microsoft.com/office/powerpoint/2010/main" Requires="p14">
+      <p:transition spd="slow" p14:dur="2000" advTm="3808"/>
+    </mc:Choice>
+    <mc:Fallback>
+      <p:transition spd="slow" advTm="3808"/>
+    </mc:Fallback>
+  </mc:AlternateContent>
+  <p:timing>
+    <p:tnLst>
+      <p:par>
+        <p:cTn id="1" dur="indefinite" restart="never" nodeType="tmRoot">
+          <p:childTnLst>
+            <p:seq concurrent="1" nextAc="seek">
+              <p:cTn id="2" dur="indefinite" nodeType="mainSeq">
+                <p:childTnLst>
+                  <p:par>
+                    <p:cTn id="3" fill="hold">
+                      <p:stCondLst>
+                        <p:cond delay="indefinite"/>
+                        <p:cond evt="onBegin" delay="0">
+                          <p:tn val="2"/>
+                        </p:cond>
+                      </p:stCondLst>
+                      <p:childTnLst>
+                        <p:par>
+                          <p:cTn id="4" fill="hold">
+                            <p:stCondLst>
+                              <p:cond delay="0"/>
+                            </p:stCondLst>
+                            <p:childTnLst>
+                              <p:par>
+                                <p:cTn id="5" presetID="1" presetClass="mediacall" presetSubtype="0" fill="hold" nodeType="afterEffect">
+                                  <p:stCondLst>
+                                    <p:cond delay="0"/>
+                                  </p:stCondLst>
+                                  <p:childTnLst>
+                                    <p:cmd type="call" cmd="playFrom(0.0)">
+                                      <p:cBhvr>
+                                        <p:cTn id="6" dur="1" fill="hold"/>
+                                        <p:tgtEl>
+                                          <p:spTgt spid="3"/>
+                                        </p:tgtEl>
+                                      </p:cBhvr>
+                                    </p:cmd>
+                                  </p:childTnLst>
+                                </p:cTn>
+                              </p:par>
+                            </p:childTnLst>
+                          </p:cTn>
+                        </p:par>
+                      </p:childTnLst>
+                    </p:cTn>
+                  </p:par>
+                </p:childTnLst>
+              </p:cTn>
+              <p:prevCondLst>
+                <p:cond evt="onPrev" delay="0">
+                  <p:tgtEl>
+                    <p:sldTgt/>
+                  </p:tgtEl>
+                </p:cond>
+              </p:prevCondLst>
+              <p:nextCondLst>
+                <p:cond evt="onNext" delay="0">
+                  <p:tgtEl>
+                    <p:sldTgt/>
+                  </p:tgtEl>
+                </p:cond>
+              </p:nextCondLst>
+            </p:seq>
+            <p:audio isNarration="1">
+              <p:cMediaNode vol="80000" showWhenStopped="0">
+                <p:cTn id="7" fill="hold" display="0">
+                  <p:stCondLst>
+                    <p:cond delay="indefinite"/>
+                  </p:stCondLst>
+                  <p:endCondLst>
+                    <p:cond evt="onStopAudio" delay="0">
+                      <p:tgtEl>
+                        <p:sldTgt/>
+                      </p:tgtEl>
+                    </p:cond>
+                  </p:endCondLst>
+                </p:cTn>
+                <p:tgtEl>
+                  <p:spTgt spid="3"/>
+                </p:tgtEl>
+              </p:cMediaNode>
+            </p:audio>
+          </p:childTnLst>
+        </p:cTn>
+      </p:par>
+    </p:tnLst>
+  </p:timing>
 </p:sld>
 </file>
 
@@ -4652,11 +5446,143 @@
           </a:p>
         </p:txBody>
       </p:sp>
+      <p:pic>
+        <p:nvPicPr>
+          <p:cNvPr id="5" name="Audio 4">
+            <a:extLst>
+              <a:ext uri="{FF2B5EF4-FFF2-40B4-BE49-F238E27FC236}">
+                <a16:creationId xmlns:a16="http://schemas.microsoft.com/office/drawing/2014/main" id="{A6928FD8-6BC0-6420-26F0-265CAD658F9E}"/>
+              </a:ext>
+            </a:extLst>
+          </p:cNvPr>
+          <p:cNvPicPr>
+            <a:picLocks noChangeAspect="1"/>
+          </p:cNvPicPr>
+          <p:nvPr>
+            <a:audioFile r:link="rId2"/>
+            <p:extLst>
+              <p:ext uri="{DAA4B4D4-6D71-4841-9C94-3DE7FCFB9230}">
+                <p14:media xmlns:p14="http://schemas.microsoft.com/office/powerpoint/2010/main" r:embed="rId1"/>
+              </p:ext>
+            </p:extLst>
+          </p:nvPr>
+        </p:nvPicPr>
+        <p:blipFill>
+          <a:blip r:embed="rId5"/>
+          <a:stretch>
+            <a:fillRect/>
+          </a:stretch>
+        </p:blipFill>
+        <p:spPr>
+          <a:xfrm>
+            <a:off x="8178800" y="5892800"/>
+            <a:ext cx="812800" cy="812800"/>
+          </a:xfrm>
+          <a:prstGeom prst="rect">
+            <a:avLst/>
+          </a:prstGeom>
+        </p:spPr>
+      </p:pic>
     </p:spTree>
   </p:cSld>
   <p:clrMapOvr>
     <a:masterClrMapping/>
   </p:clrMapOvr>
+  <mc:AlternateContent xmlns:mc="http://schemas.openxmlformats.org/markup-compatibility/2006">
+    <mc:Choice xmlns:p14="http://schemas.microsoft.com/office/powerpoint/2010/main" Requires="p14">
+      <p:transition spd="slow" p14:dur="2000" advTm="59402"/>
+    </mc:Choice>
+    <mc:Fallback>
+      <p:transition spd="slow" advTm="59402"/>
+    </mc:Fallback>
+  </mc:AlternateContent>
+  <p:timing>
+    <p:tnLst>
+      <p:par>
+        <p:cTn id="1" dur="indefinite" restart="never" nodeType="tmRoot">
+          <p:childTnLst>
+            <p:seq concurrent="1" nextAc="seek">
+              <p:cTn id="2" dur="indefinite" nodeType="mainSeq">
+                <p:childTnLst>
+                  <p:par>
+                    <p:cTn id="3" fill="hold">
+                      <p:stCondLst>
+                        <p:cond delay="indefinite"/>
+                        <p:cond evt="onBegin" delay="0">
+                          <p:tn val="2"/>
+                        </p:cond>
+                      </p:stCondLst>
+                      <p:childTnLst>
+                        <p:par>
+                          <p:cTn id="4" fill="hold">
+                            <p:stCondLst>
+                              <p:cond delay="0"/>
+                            </p:stCondLst>
+                            <p:childTnLst>
+                              <p:par>
+                                <p:cTn id="5" presetID="1" presetClass="mediacall" presetSubtype="0" fill="hold" nodeType="afterEffect">
+                                  <p:stCondLst>
+                                    <p:cond delay="0"/>
+                                  </p:stCondLst>
+                                  <p:childTnLst>
+                                    <p:cmd type="call" cmd="playFrom(0.0)">
+                                      <p:cBhvr>
+                                        <p:cTn id="6" dur="1" fill="hold"/>
+                                        <p:tgtEl>
+                                          <p:spTgt spid="5"/>
+                                        </p:tgtEl>
+                                      </p:cBhvr>
+                                    </p:cmd>
+                                  </p:childTnLst>
+                                </p:cTn>
+                              </p:par>
+                            </p:childTnLst>
+                          </p:cTn>
+                        </p:par>
+                      </p:childTnLst>
+                    </p:cTn>
+                  </p:par>
+                </p:childTnLst>
+              </p:cTn>
+              <p:prevCondLst>
+                <p:cond evt="onPrev" delay="0">
+                  <p:tgtEl>
+                    <p:sldTgt/>
+                  </p:tgtEl>
+                </p:cond>
+              </p:prevCondLst>
+              <p:nextCondLst>
+                <p:cond evt="onNext" delay="0">
+                  <p:tgtEl>
+                    <p:sldTgt/>
+                  </p:tgtEl>
+                </p:cond>
+              </p:nextCondLst>
+            </p:seq>
+            <p:audio isNarration="1">
+              <p:cMediaNode vol="80000" showWhenStopped="0">
+                <p:cTn id="7" fill="hold" display="0">
+                  <p:stCondLst>
+                    <p:cond delay="indefinite"/>
+                  </p:stCondLst>
+                  <p:endCondLst>
+                    <p:cond evt="onStopAudio" delay="0">
+                      <p:tgtEl>
+                        <p:sldTgt/>
+                      </p:tgtEl>
+                    </p:cond>
+                  </p:endCondLst>
+                </p:cTn>
+                <p:tgtEl>
+                  <p:spTgt spid="5"/>
+                </p:tgtEl>
+              </p:cMediaNode>
+            </p:audio>
+          </p:childTnLst>
+        </p:cTn>
+      </p:par>
+    </p:tnLst>
+  </p:timing>
 </p:sld>
 </file>
 
@@ -4769,11 +5695,143 @@
           </a:p>
         </p:txBody>
       </p:sp>
+      <p:pic>
+        <p:nvPicPr>
+          <p:cNvPr id="5" name="Audio 4">
+            <a:extLst>
+              <a:ext uri="{FF2B5EF4-FFF2-40B4-BE49-F238E27FC236}">
+                <a16:creationId xmlns:a16="http://schemas.microsoft.com/office/drawing/2014/main" id="{774736F2-1F20-4DE3-169A-B68261A921B4}"/>
+              </a:ext>
+            </a:extLst>
+          </p:cNvPr>
+          <p:cNvPicPr>
+            <a:picLocks noChangeAspect="1"/>
+          </p:cNvPicPr>
+          <p:nvPr>
+            <a:audioFile r:link="rId2"/>
+            <p:extLst>
+              <p:ext uri="{DAA4B4D4-6D71-4841-9C94-3DE7FCFB9230}">
+                <p14:media xmlns:p14="http://schemas.microsoft.com/office/powerpoint/2010/main" r:embed="rId1"/>
+              </p:ext>
+            </p:extLst>
+          </p:nvPr>
+        </p:nvPicPr>
+        <p:blipFill>
+          <a:blip r:embed="rId5"/>
+          <a:stretch>
+            <a:fillRect/>
+          </a:stretch>
+        </p:blipFill>
+        <p:spPr>
+          <a:xfrm>
+            <a:off x="8178800" y="5892800"/>
+            <a:ext cx="812800" cy="812800"/>
+          </a:xfrm>
+          <a:prstGeom prst="rect">
+            <a:avLst/>
+          </a:prstGeom>
+        </p:spPr>
+      </p:pic>
     </p:spTree>
   </p:cSld>
   <p:clrMapOvr>
     <a:masterClrMapping/>
   </p:clrMapOvr>
+  <mc:AlternateContent xmlns:mc="http://schemas.openxmlformats.org/markup-compatibility/2006">
+    <mc:Choice xmlns:p14="http://schemas.microsoft.com/office/powerpoint/2010/main" Requires="p14">
+      <p:transition spd="slow" p14:dur="2000" advTm="49653"/>
+    </mc:Choice>
+    <mc:Fallback>
+      <p:transition spd="slow" advTm="49653"/>
+    </mc:Fallback>
+  </mc:AlternateContent>
+  <p:timing>
+    <p:tnLst>
+      <p:par>
+        <p:cTn id="1" dur="indefinite" restart="never" nodeType="tmRoot">
+          <p:childTnLst>
+            <p:seq concurrent="1" nextAc="seek">
+              <p:cTn id="2" dur="indefinite" nodeType="mainSeq">
+                <p:childTnLst>
+                  <p:par>
+                    <p:cTn id="3" fill="hold">
+                      <p:stCondLst>
+                        <p:cond delay="indefinite"/>
+                        <p:cond evt="onBegin" delay="0">
+                          <p:tn val="2"/>
+                        </p:cond>
+                      </p:stCondLst>
+                      <p:childTnLst>
+                        <p:par>
+                          <p:cTn id="4" fill="hold">
+                            <p:stCondLst>
+                              <p:cond delay="0"/>
+                            </p:stCondLst>
+                            <p:childTnLst>
+                              <p:par>
+                                <p:cTn id="5" presetID="1" presetClass="mediacall" presetSubtype="0" fill="hold" nodeType="afterEffect">
+                                  <p:stCondLst>
+                                    <p:cond delay="0"/>
+                                  </p:stCondLst>
+                                  <p:childTnLst>
+                                    <p:cmd type="call" cmd="playFrom(0.0)">
+                                      <p:cBhvr>
+                                        <p:cTn id="6" dur="1" fill="hold"/>
+                                        <p:tgtEl>
+                                          <p:spTgt spid="5"/>
+                                        </p:tgtEl>
+                                      </p:cBhvr>
+                                    </p:cmd>
+                                  </p:childTnLst>
+                                </p:cTn>
+                              </p:par>
+                            </p:childTnLst>
+                          </p:cTn>
+                        </p:par>
+                      </p:childTnLst>
+                    </p:cTn>
+                  </p:par>
+                </p:childTnLst>
+              </p:cTn>
+              <p:prevCondLst>
+                <p:cond evt="onPrev" delay="0">
+                  <p:tgtEl>
+                    <p:sldTgt/>
+                  </p:tgtEl>
+                </p:cond>
+              </p:prevCondLst>
+              <p:nextCondLst>
+                <p:cond evt="onNext" delay="0">
+                  <p:tgtEl>
+                    <p:sldTgt/>
+                  </p:tgtEl>
+                </p:cond>
+              </p:nextCondLst>
+            </p:seq>
+            <p:audio isNarration="1">
+              <p:cMediaNode vol="80000" showWhenStopped="0">
+                <p:cTn id="7" fill="hold" display="0">
+                  <p:stCondLst>
+                    <p:cond delay="indefinite"/>
+                  </p:stCondLst>
+                  <p:endCondLst>
+                    <p:cond evt="onStopAudio" delay="0">
+                      <p:tgtEl>
+                        <p:sldTgt/>
+                      </p:tgtEl>
+                    </p:cond>
+                  </p:endCondLst>
+                </p:cTn>
+                <p:tgtEl>
+                  <p:spTgt spid="5"/>
+                </p:tgtEl>
+              </p:cMediaNode>
+            </p:audio>
+          </p:childTnLst>
+        </p:cTn>
+      </p:par>
+    </p:tnLst>
+  </p:timing>
 </p:sld>
 </file>
 
@@ -4886,11 +5944,143 @@
           </a:p>
         </p:txBody>
       </p:sp>
+      <p:pic>
+        <p:nvPicPr>
+          <p:cNvPr id="5" name="Audio 4">
+            <a:extLst>
+              <a:ext uri="{FF2B5EF4-FFF2-40B4-BE49-F238E27FC236}">
+                <a16:creationId xmlns:a16="http://schemas.microsoft.com/office/drawing/2014/main" id="{7A32D1A5-4C58-21EA-AD2C-71E89F0B4962}"/>
+              </a:ext>
+            </a:extLst>
+          </p:cNvPr>
+          <p:cNvPicPr>
+            <a:picLocks noChangeAspect="1"/>
+          </p:cNvPicPr>
+          <p:nvPr>
+            <a:audioFile r:link="rId2"/>
+            <p:extLst>
+              <p:ext uri="{DAA4B4D4-6D71-4841-9C94-3DE7FCFB9230}">
+                <p14:media xmlns:p14="http://schemas.microsoft.com/office/powerpoint/2010/main" r:embed="rId1"/>
+              </p:ext>
+            </p:extLst>
+          </p:nvPr>
+        </p:nvPicPr>
+        <p:blipFill>
+          <a:blip r:embed="rId5"/>
+          <a:stretch>
+            <a:fillRect/>
+          </a:stretch>
+        </p:blipFill>
+        <p:spPr>
+          <a:xfrm>
+            <a:off x="8178800" y="5892800"/>
+            <a:ext cx="812800" cy="812800"/>
+          </a:xfrm>
+          <a:prstGeom prst="rect">
+            <a:avLst/>
+          </a:prstGeom>
+        </p:spPr>
+      </p:pic>
     </p:spTree>
   </p:cSld>
   <p:clrMapOvr>
     <a:masterClrMapping/>
   </p:clrMapOvr>
+  <mc:AlternateContent xmlns:mc="http://schemas.openxmlformats.org/markup-compatibility/2006">
+    <mc:Choice xmlns:p14="http://schemas.microsoft.com/office/powerpoint/2010/main" Requires="p14">
+      <p:transition spd="slow" p14:dur="2000" advTm="45269"/>
+    </mc:Choice>
+    <mc:Fallback>
+      <p:transition spd="slow" advTm="45269"/>
+    </mc:Fallback>
+  </mc:AlternateContent>
+  <p:timing>
+    <p:tnLst>
+      <p:par>
+        <p:cTn id="1" dur="indefinite" restart="never" nodeType="tmRoot">
+          <p:childTnLst>
+            <p:seq concurrent="1" nextAc="seek">
+              <p:cTn id="2" dur="indefinite" nodeType="mainSeq">
+                <p:childTnLst>
+                  <p:par>
+                    <p:cTn id="3" fill="hold">
+                      <p:stCondLst>
+                        <p:cond delay="indefinite"/>
+                        <p:cond evt="onBegin" delay="0">
+                          <p:tn val="2"/>
+                        </p:cond>
+                      </p:stCondLst>
+                      <p:childTnLst>
+                        <p:par>
+                          <p:cTn id="4" fill="hold">
+                            <p:stCondLst>
+                              <p:cond delay="0"/>
+                            </p:stCondLst>
+                            <p:childTnLst>
+                              <p:par>
+                                <p:cTn id="5" presetID="1" presetClass="mediacall" presetSubtype="0" fill="hold" nodeType="afterEffect">
+                                  <p:stCondLst>
+                                    <p:cond delay="0"/>
+                                  </p:stCondLst>
+                                  <p:childTnLst>
+                                    <p:cmd type="call" cmd="playFrom(0.0)">
+                                      <p:cBhvr>
+                                        <p:cTn id="6" dur="1" fill="hold"/>
+                                        <p:tgtEl>
+                                          <p:spTgt spid="5"/>
+                                        </p:tgtEl>
+                                      </p:cBhvr>
+                                    </p:cmd>
+                                  </p:childTnLst>
+                                </p:cTn>
+                              </p:par>
+                            </p:childTnLst>
+                          </p:cTn>
+                        </p:par>
+                      </p:childTnLst>
+                    </p:cTn>
+                  </p:par>
+                </p:childTnLst>
+              </p:cTn>
+              <p:prevCondLst>
+                <p:cond evt="onPrev" delay="0">
+                  <p:tgtEl>
+                    <p:sldTgt/>
+                  </p:tgtEl>
+                </p:cond>
+              </p:prevCondLst>
+              <p:nextCondLst>
+                <p:cond evt="onNext" delay="0">
+                  <p:tgtEl>
+                    <p:sldTgt/>
+                  </p:tgtEl>
+                </p:cond>
+              </p:nextCondLst>
+            </p:seq>
+            <p:audio isNarration="1">
+              <p:cMediaNode vol="80000" showWhenStopped="0">
+                <p:cTn id="7" fill="hold" display="0">
+                  <p:stCondLst>
+                    <p:cond delay="indefinite"/>
+                  </p:stCondLst>
+                  <p:endCondLst>
+                    <p:cond evt="onStopAudio" delay="0">
+                      <p:tgtEl>
+                        <p:sldTgt/>
+                      </p:tgtEl>
+                    </p:cond>
+                  </p:endCondLst>
+                </p:cTn>
+                <p:tgtEl>
+                  <p:spTgt spid="5"/>
+                </p:tgtEl>
+              </p:cMediaNode>
+            </p:audio>
+          </p:childTnLst>
+        </p:cTn>
+      </p:par>
+    </p:tnLst>
+  </p:timing>
 </p:sld>
 </file>
 

</xml_diff>